<commit_message>
docs(delivery): align final architecture package
</commit_message>
<xml_diff>
--- a/docs/presentations/AI_Werewolf_Project_Report.pptx
+++ b/docs/presentations/AI_Werewolf_Project_Report.pptx
@@ -3311,7 +3311,7 @@
                 </a:solidFill>
                 <a:latin typeface="Microsoft YaHei"/>
               </a:rPr>
-              <a:t>Track B 逐步评分复盘，Track C 策略知识回流</a:t>
+              <a:t>Track B 决策复盘评价，Track C 策略知识回流</a:t>
             </a:r>
           </a:p>
         </p:txBody>
@@ -3579,7 +3579,7 @@
               </a:defRPr>
             </a:pPr>
             <a:r>
-              <a:t>Track B：逐步评分与复盘</a:t>
+              <a:t>Track B：决策复盘评价</a:t>
             </a:r>
           </a:p>
         </p:txBody>
@@ -3749,7 +3749,7 @@
               </a:defRPr>
             </a:pPr>
             <a:r>
-              <a:t>三级打分级联</a:t>
+              <a:t>三级评价链路</a:t>
             </a:r>
           </a:p>
         </p:txBody>
@@ -3986,7 +3986,7 @@
               </a:defRPr>
             </a:pPr>
             <a:r>
-              <a:t>Tier 3 评审团</a:t>
+              <a:t>Tier 3 复核</a:t>
             </a:r>
           </a:p>
         </p:txBody>
@@ -4084,7 +4084,7 @@
                 </a:solidFill>
                 <a:latin typeface="Microsoft YaHei"/>
               </a:rPr>
-              <a:t>高影响决策可进入评审团，保留 counterfactual 和证据引用</a:t>
+              <a:t>高影响决策可进入复核流程，保留 counterfactual 和证据引用</a:t>
             </a:r>
           </a:p>
         </p:txBody>
@@ -6188,7 +6188,7 @@
               </a:defRPr>
             </a:pPr>
             <a:r>
-              <a:t>Next.js 观战 UI、Human 模式、复盘与进化看板</a:t>
+              <a:t>Next.js 观战 UI、Human 模式、复盘与评测仪表盘</a:t>
             </a:r>
           </a:p>
         </p:txBody>
@@ -6922,7 +6922,7 @@
           </a:solidFill>
           <a:ln w="12700">
             <a:solidFill>
-              <a:srgbClr val="C8524A"/>
+              <a:srgbClr val="5CA7D8"/>
             </a:solidFill>
           </a:ln>
         </p:spPr>
@@ -6973,13 +6973,13 @@
             <a:pPr algn="l">
               <a:defRPr sz="1000" b="1">
                 <a:solidFill>
-                  <a:srgbClr val="C8524A"/>
+                  <a:srgbClr val="5CA7D8"/>
                 </a:solidFill>
                 <a:latin typeface="Aptos"/>
               </a:defRPr>
             </a:pPr>
             <a:r>
-              <a:t>/evolution</a:t>
+              <a:t>/eval/dashboard</a:t>
             </a:r>
           </a:p>
         </p:txBody>
@@ -7015,7 +7015,7 @@
               </a:defRPr>
             </a:pPr>
             <a:r>
-              <a:t>策略进化看板</a:t>
+              <a:t>评测仪表盘</a:t>
             </a:r>
           </a:p>
         </p:txBody>
@@ -7065,159 +7065,6 @@
         <p:spPr>
           <a:xfrm>
             <a:off x="6099048" y="3337560"/>
-            <a:ext cx="4754880" cy="658368"/>
-          </a:xfrm>
-          <a:prstGeom prst="roundRect">
-            <a:avLst/>
-          </a:prstGeom>
-          <a:solidFill>
-            <a:srgbClr val="182538"/>
-          </a:solidFill>
-          <a:ln w="12700">
-            <a:solidFill>
-              <a:srgbClr val="5CA7D8"/>
-            </a:solidFill>
-          </a:ln>
-        </p:spPr>
-        <p:style>
-          <a:lnRef idx="1">
-            <a:schemeClr val="accent1"/>
-          </a:lnRef>
-          <a:fillRef idx="3">
-            <a:schemeClr val="accent1"/>
-          </a:fillRef>
-          <a:effectRef idx="2">
-            <a:schemeClr val="accent1"/>
-          </a:effectRef>
-          <a:fontRef idx="minor">
-            <a:schemeClr val="lt1"/>
-          </a:fontRef>
-        </p:style>
-        <p:txBody>
-          <a:bodyPr rtlCol="0" anchor="ctr"/>
-          <a:lstStyle/>
-          <a:p>
-            <a:pPr algn="ctr"/>
-          </a:p>
-        </p:txBody>
-      </p:sp>
-      <p:sp>
-        <p:nvSpPr>
-          <p:cNvPr id="27" name="TextBox 26"/>
-          <p:cNvSpPr txBox="1"/>
-          <p:nvPr/>
-        </p:nvSpPr>
-        <p:spPr>
-          <a:xfrm>
-            <a:off x="6263640" y="3447288"/>
-            <a:ext cx="1783080" cy="219456"/>
-          </a:xfrm>
-          <a:prstGeom prst="rect">
-            <a:avLst/>
-          </a:prstGeom>
-          <a:noFill/>
-        </p:spPr>
-        <p:txBody>
-          <a:bodyPr wrap="square" anchor="t" lIns="36576" rIns="36576" tIns="36576" bIns="36576">
-            <a:spAutoFit/>
-          </a:bodyPr>
-          <a:lstStyle/>
-          <a:p>
-            <a:pPr algn="l">
-              <a:defRPr sz="1000" b="1">
-                <a:solidFill>
-                  <a:srgbClr val="5CA7D8"/>
-                </a:solidFill>
-                <a:latin typeface="Aptos"/>
-              </a:defRPr>
-            </a:pPr>
-            <a:r>
-              <a:t>/eval/dashboard</a:t>
-            </a:r>
-          </a:p>
-        </p:txBody>
-      </p:sp>
-      <p:sp>
-        <p:nvSpPr>
-          <p:cNvPr id="28" name="TextBox 27"/>
-          <p:cNvSpPr txBox="1"/>
-          <p:nvPr/>
-        </p:nvSpPr>
-        <p:spPr>
-          <a:xfrm>
-            <a:off x="8110728" y="3447288"/>
-            <a:ext cx="2423160" cy="219456"/>
-          </a:xfrm>
-          <a:prstGeom prst="rect">
-            <a:avLst/>
-          </a:prstGeom>
-          <a:noFill/>
-        </p:spPr>
-        <p:txBody>
-          <a:bodyPr wrap="square" anchor="t" lIns="36576" rIns="36576" tIns="36576" bIns="36576">
-            <a:spAutoFit/>
-          </a:bodyPr>
-          <a:lstStyle/>
-          <a:p>
-            <a:pPr algn="l">
-              <a:defRPr sz="1200" b="1">
-                <a:solidFill>
-                  <a:srgbClr val="F7F2E8"/>
-                </a:solidFill>
-                <a:latin typeface="Microsoft YaHei"/>
-              </a:defRPr>
-            </a:pPr>
-            <a:r>
-              <a:t>评测仪表盘</a:t>
-            </a:r>
-          </a:p>
-        </p:txBody>
-      </p:sp>
-      <p:sp>
-        <p:nvSpPr>
-          <p:cNvPr id="29" name="TextBox 28"/>
-          <p:cNvSpPr txBox="1"/>
-          <p:nvPr/>
-        </p:nvSpPr>
-        <p:spPr>
-          <a:xfrm>
-            <a:off x="8110728" y="3703320"/>
-            <a:ext cx="2423160" cy="164592"/>
-          </a:xfrm>
-          <a:prstGeom prst="rect">
-            <a:avLst/>
-          </a:prstGeom>
-          <a:noFill/>
-        </p:spPr>
-        <p:txBody>
-          <a:bodyPr wrap="square" anchor="t" lIns="36576" rIns="36576" tIns="36576" bIns="36576">
-            <a:spAutoFit/>
-          </a:bodyPr>
-          <a:lstStyle/>
-          <a:p>
-            <a:pPr algn="l">
-              <a:defRPr sz="800" b="0">
-                <a:solidFill>
-                  <a:srgbClr val="B8C2D1"/>
-                </a:solidFill>
-                <a:latin typeface="Microsoft YaHei"/>
-              </a:defRPr>
-            </a:pPr>
-            <a:r>
-              <a:t>已纳入 build / UI smoke 验证</a:t>
-            </a:r>
-          </a:p>
-        </p:txBody>
-      </p:sp>
-      <p:sp>
-        <p:nvSpPr>
-          <p:cNvPr id="30" name="Rounded Rectangle 29"/>
-          <p:cNvSpPr/>
-          <p:nvPr/>
-        </p:nvSpPr>
-        <p:spPr>
-          <a:xfrm>
-            <a:off x="749808" y="4297680"/>
             <a:ext cx="4754880" cy="658368"/>
           </a:xfrm>
           <a:prstGeom prst="roundRect">
@@ -7256,13 +7103,13 @@
       </p:sp>
       <p:sp>
         <p:nvSpPr>
-          <p:cNvPr id="31" name="TextBox 30"/>
-          <p:cNvSpPr txBox="1"/>
-          <p:nvPr/>
-        </p:nvSpPr>
-        <p:spPr>
-          <a:xfrm>
-            <a:off x="914400" y="4407408"/>
+          <p:cNvPr id="27" name="TextBox 26"/>
+          <p:cNvSpPr txBox="1"/>
+          <p:nvPr/>
+        </p:nvSpPr>
+        <p:spPr>
+          <a:xfrm>
+            <a:off x="6263640" y="3447288"/>
             <a:ext cx="1783080" cy="219456"/>
           </a:xfrm>
           <a:prstGeom prst="rect">
@@ -7292,13 +7139,13 @@
       </p:sp>
       <p:sp>
         <p:nvSpPr>
-          <p:cNvPr id="32" name="TextBox 31"/>
-          <p:cNvSpPr txBox="1"/>
-          <p:nvPr/>
-        </p:nvSpPr>
-        <p:spPr>
-          <a:xfrm>
-            <a:off x="2761488" y="4407408"/>
+          <p:cNvPr id="28" name="TextBox 27"/>
+          <p:cNvSpPr txBox="1"/>
+          <p:nvPr/>
+        </p:nvSpPr>
+        <p:spPr>
+          <a:xfrm>
+            <a:off x="8110728" y="3447288"/>
             <a:ext cx="2423160" cy="219456"/>
           </a:xfrm>
           <a:prstGeom prst="rect">
@@ -7328,13 +7175,13 @@
       </p:sp>
       <p:sp>
         <p:nvSpPr>
-          <p:cNvPr id="33" name="TextBox 32"/>
-          <p:cNvSpPr txBox="1"/>
-          <p:nvPr/>
-        </p:nvSpPr>
-        <p:spPr>
-          <a:xfrm>
-            <a:off x="2761488" y="4663440"/>
+          <p:cNvPr id="29" name="TextBox 28"/>
+          <p:cNvSpPr txBox="1"/>
+          <p:nvPr/>
+        </p:nvSpPr>
+        <p:spPr>
+          <a:xfrm>
+            <a:off x="8110728" y="3703320"/>
             <a:ext cx="2423160" cy="164592"/>
           </a:xfrm>
           <a:prstGeom prst="rect">
@@ -7364,7 +7211,7 @@
       </p:sp>
       <p:sp>
         <p:nvSpPr>
-          <p:cNvPr id="34" name="Rounded Rectangle 33"/>
+          <p:cNvPr id="30" name="Rounded Rectangle 29"/>
           <p:cNvSpPr/>
           <p:nvPr/>
         </p:nvSpPr>
@@ -7409,7 +7256,7 @@
       </p:sp>
       <p:sp>
         <p:nvSpPr>
-          <p:cNvPr id="35" name="TextBox 34"/>
+          <p:cNvPr id="31" name="TextBox 30"/>
           <p:cNvSpPr txBox="1"/>
           <p:nvPr/>
         </p:nvSpPr>
@@ -7438,14 +7285,14 @@
               </a:defRPr>
             </a:pPr>
             <a:r>
-              <a:t>UI smoke 覆盖：进化页加载、对局到 GAME_END、复盘 iframe、HTML 复盘资产、中英文切换、AI/Human 房间流程。</a:t>
-            </a:r>
-          </a:p>
-        </p:txBody>
-      </p:sp>
-      <p:sp>
-        <p:nvSpPr>
-          <p:cNvPr id="36" name="TextBox 35"/>
+              <a:t>UI smoke 覆盖：对局到 GAME_END、复盘 iframe、HTML 复盘资产、中英文切换、AI/Human 房间流程。</a:t>
+            </a:r>
+          </a:p>
+        </p:txBody>
+      </p:sp>
+      <p:sp>
+        <p:nvSpPr>
+          <p:cNvPr id="32" name="TextBox 31"/>
           <p:cNvSpPr txBox="1"/>
           <p:nvPr/>
         </p:nvSpPr>
@@ -7481,7 +7328,7 @@
       </p:sp>
       <p:sp>
         <p:nvSpPr>
-          <p:cNvPr id="37" name="TextBox 36"/>
+          <p:cNvPr id="33" name="TextBox 32"/>
           <p:cNvSpPr txBox="1"/>
           <p:nvPr/>
         </p:nvSpPr>
@@ -10336,7 +10183,7 @@
               </a:defRPr>
             </a:pPr>
             <a:r>
-              <a:t>事件、决策、评分、复盘全链路可追溯</a:t>
+              <a:t>事件、决策、复盘全链路可追溯</a:t>
             </a:r>
           </a:p>
         </p:txBody>
@@ -12462,7 +12309,7 @@
               </a:defRPr>
             </a:pPr>
             <a:r>
-              <a:t>每步决策可评分、可解释，并沉淀为下一局策略</a:t>
+              <a:t>每步决策可审计、可解释，并沉淀为下一局策略</a:t>
             </a:r>
           </a:p>
         </p:txBody>
@@ -12816,7 +12663,7 @@
               </a:defRPr>
             </a:pPr>
             <a:r>
-              <a:t>系统闭环：对局执行 → 赛后评分 → 经验抽取 → 下一局策略回流</a:t>
+              <a:t>系统闭环：对局执行 → 赛后复盘 → 经验抽取 → 下一局策略回流</a:t>
             </a:r>
           </a:p>
         </p:txBody>
@@ -13515,7 +13362,7 @@
                 </a:solidFill>
                 <a:latin typeface="Microsoft YaHei"/>
               </a:rPr>
-              <a:t>PostgreSQL 保存事件、快照、决策、评分、复盘和知识</a:t>
+              <a:t>PostgreSQL 保存事件、快照、决策、复盘和知识</a:t>
             </a:r>
           </a:p>
           <a:p>
@@ -14595,7 +14442,7 @@
                 </a:solidFill>
                 <a:latin typeface="Microsoft YaHei"/>
               </a:rPr>
-              <a:t>终局后自动形成可回放、可评分、可抽取知识的证据链</a:t>
+              <a:t>终局后自动形成可回放、可审计、可抽取知识的证据链</a:t>
             </a:r>
           </a:p>
         </p:txBody>
@@ -15250,7 +15097,7 @@
                         </a:defRPr>
                       </a:pPr>
                       <a:r>
-                        <a:t>逐步评分、复盘、证据引用</a:t>
+                        <a:t>决策审计、复盘、证据引用</a:t>
                       </a:r>
                     </a:p>
                   </a:txBody>
@@ -15398,7 +15245,7 @@
                         </a:defRPr>
                       </a:pPr>
                       <a:r>
-                        <a:t>大厅、观战、Human、复盘、进化看板</a:t>
+                        <a:t>大厅、观战、Human、复盘、仪表盘</a:t>
                       </a:r>
                     </a:p>
                   </a:txBody>
@@ -18603,7 +18450,7 @@
               </a:defRPr>
             </a:pPr>
             <a:r>
-              <a:t>Track B 逐步评分，生成 ScoredStep 和 PublishedReview</a:t>
+              <a:t>Track B 评价关键决策，生成 ScoredStep 和 PublishedReview</a:t>
             </a:r>
           </a:p>
         </p:txBody>

</xml_diff>